<commit_message>
docs(intermodular): polish Tarea 0 files with student name and natural voice
</commit_message>
<xml_diff>
--- a/Proyecto intermodular/UD1/Tarea0-2DAM/Tarea0_Memorix_Presentacion.pptx
+++ b/Proyecto intermodular/UD1/Tarea0-2DAM/Tarea0_Memorix_Presentacion.pptx
@@ -3150,11 +3150,11 @@
             <a:avLst/>
           </a:prstGeom>
           <a:solidFill>
-            <a:srgbClr val="00D2B4"/>
+            <a:srgbClr val="00B496"/>
           </a:solidFill>
           <a:ln>
             <a:solidFill>
-              <a:srgbClr val="00D2B4"/>
+              <a:srgbClr val="00B496"/>
             </a:solidFill>
           </a:ln>
         </p:spPr>
@@ -3205,7 +3205,7 @@
             <a:pPr>
               <a:defRPr sz="1200" b="1">
                 <a:solidFill>
-                  <a:srgbClr val="00D2B4"/>
+                  <a:srgbClr val="00B496"/>
                 </a:solidFill>
                 <a:latin typeface="Calibri"/>
               </a:defRPr>
@@ -3286,7 +3286,7 @@
               </a:defRPr>
             </a:pPr>
             <a:r>
-              <a:t>1. Problema y Necesidad Detectada</a:t>
+              <a:t>1. Diagnóstico del Problema y Colectivos Afectados</a:t>
             </a:r>
           </a:p>
           <a:p>
@@ -3299,7 +3299,7 @@
               </a:defRPr>
             </a:pPr>
             <a:r>
-              <a:t>¿Qué ocurre en la realidad diaria y a quién afecta?</a:t>
+              <a:t>¿Qué ocurre en la vida cotidiana y a quién afecta directamente?</a:t>
             </a:r>
           </a:p>
         </p:txBody>
@@ -3399,23 +3399,23 @@
               </a:defRPr>
             </a:pPr>
             <a:r>
-              <a:t>• 50% de Abandono Terapéutico: </a:t>
+              <a:t>• Olvidos y Confusión en la Medicación: </a:t>
             </a:r>
           </a:p>
           <a:p>
             <a:pPr>
               <a:spcAft>
-                <a:spcPts val="800"/>
+                <a:spcPts val="1000"/>
               </a:spcAft>
-              <a:defRPr sz="1050">
-                <a:solidFill>
-                  <a:srgbClr val="1E293B"/>
-                </a:solidFill>
-                <a:latin typeface="Calibri"/>
-              </a:defRPr>
-            </a:pPr>
-            <a:r>
-              <a:t>   Casi la mitad de enfermos crónicos no toman su medicación correctamente (OMS), provocando recaídas y urgencias.</a:t>
+              <a:defRPr sz="1100">
+                <a:solidFill>
+                  <a:srgbClr val="232F3E"/>
+                </a:solidFill>
+                <a:latin typeface="Calibri"/>
+              </a:defRPr>
+            </a:pPr>
+            <a:r>
+              <a:t>   Casi el 50% de pacientes crónicos no toma bien su tratamiento (OMS), provocando recaídas y visitas a urgencias.</a:t>
             </a:r>
           </a:p>
           <a:p>
@@ -3431,23 +3431,23 @@
               </a:defRPr>
             </a:pPr>
             <a:r>
-              <a:t>• Olvidos y Confusión de Dosis: </a:t>
+              <a:t>• Dificultad con Posologías y Prospectos: </a:t>
             </a:r>
           </a:p>
           <a:p>
             <a:pPr>
               <a:spcAft>
-                <a:spcPts val="800"/>
+                <a:spcPts val="1000"/>
               </a:spcAft>
-              <a:defRPr sz="1050">
-                <a:solidFill>
-                  <a:srgbClr val="1E293B"/>
-                </a:solidFill>
-                <a:latin typeface="Calibri"/>
-              </a:defRPr>
-            </a:pPr>
-            <a:r>
-              <a:t>   Múltiples pastillas diarias provocan tomas duplicadas o dosis omitidas por no recordar las horas.</a:t>
+              <a:defRPr sz="1100">
+                <a:solidFill>
+                  <a:srgbClr val="232F3E"/>
+                </a:solidFill>
+                <a:latin typeface="Calibri"/>
+              </a:defRPr>
+            </a:pPr>
+            <a:r>
+              <a:t>   La letra diminuta y las explicaciones técnicas confunden al paciente sobre cómo y cuándo tomar cada pastilla.</a:t>
             </a:r>
           </a:p>
           <a:p>
@@ -3463,55 +3463,23 @@
               </a:defRPr>
             </a:pPr>
             <a:r>
-              <a:t>• Prospectos Inaccesibles: </a:t>
+              <a:t>• Abandono de la Rehabilitación en Casa: </a:t>
             </a:r>
           </a:p>
           <a:p>
             <a:pPr>
               <a:spcAft>
-                <a:spcPts val="800"/>
+                <a:spcPts val="1000"/>
               </a:spcAft>
-              <a:defRPr sz="1050">
-                <a:solidFill>
-                  <a:srgbClr val="1E293B"/>
-                </a:solidFill>
-                <a:latin typeface="Calibri"/>
-              </a:defRPr>
-            </a:pPr>
-            <a:r>
-              <a:t>   Texto minúsculo e instrucciones farmacológicas complejas que generan inseguridad.</a:t>
-            </a:r>
-          </a:p>
-          <a:p>
-            <a:pPr>
-              <a:spcAft>
-                <a:spcPts val="100"/>
-              </a:spcAft>
-              <a:defRPr sz="1200" b="1">
-                <a:solidFill>
-                  <a:srgbClr val="050C26"/>
-                </a:solidFill>
-                <a:latin typeface="Calibri"/>
-              </a:defRPr>
-            </a:pPr>
-            <a:r>
-              <a:t>• Rehabilitación en Papel Ineficaz: </a:t>
-            </a:r>
-          </a:p>
-          <a:p>
-            <a:pPr>
-              <a:spcAft>
-                <a:spcPts val="800"/>
-              </a:spcAft>
-              <a:defRPr sz="1050">
-                <a:solidFill>
-                  <a:srgbClr val="1E293B"/>
-                </a:solidFill>
-                <a:latin typeface="Calibri"/>
-              </a:defRPr>
-            </a:pPr>
-            <a:r>
-              <a:t>   Las rutinas de ejercicios para traumatismos o dolor muscular se olvidan o se ejecutan sin técnica adecuada.</a:t>
+              <a:defRPr sz="1100">
+                <a:solidFill>
+                  <a:srgbClr val="232F3E"/>
+                </a:solidFill>
+                <a:latin typeface="Calibri"/>
+              </a:defRPr>
+            </a:pPr>
+            <a:r>
+              <a:t>   Las hojas de papel con ejercicios para dolores musculares o traumatismos se extravían y no guían la postura correcta.</a:t>
             </a:r>
           </a:p>
         </p:txBody>
@@ -3611,23 +3579,23 @@
               </a:defRPr>
             </a:pPr>
             <a:r>
-              <a:t>• Mayores y Pacientes de Alzheimer: </a:t>
+              <a:t>• Personas Mayores y Pacientes con Olvidos: </a:t>
             </a:r>
           </a:p>
           <a:p>
             <a:pPr>
               <a:spcAft>
-                <a:spcPts val="800"/>
+                <a:spcPts val="1000"/>
               </a:spcAft>
-              <a:defRPr sz="1050">
-                <a:solidFill>
-                  <a:srgbClr val="1E293B"/>
-                </a:solidFill>
-                <a:latin typeface="Calibri"/>
-              </a:defRPr>
-            </a:pPr>
-            <a:r>
-              <a:t>   Vulnerabilidad extrema ante polimedicación y despistes por deterioro cognitivo.</a:t>
+              <a:defRPr sz="1100">
+                <a:solidFill>
+                  <a:srgbClr val="232F3E"/>
+                </a:solidFill>
+                <a:latin typeface="Calibri"/>
+              </a:defRPr>
+            </a:pPr>
+            <a:r>
+              <a:t>   Especialmente vulnerables por polimedicación o principios de Alzheimer y deterioro cognitivo leve.</a:t>
             </a:r>
           </a:p>
           <a:p>
@@ -3643,23 +3611,23 @@
               </a:defRPr>
             </a:pPr>
             <a:r>
-              <a:t>• Cuidadores y Familias: </a:t>
+              <a:t>• Familiares y Cuidadores: </a:t>
             </a:r>
           </a:p>
           <a:p>
             <a:pPr>
               <a:spcAft>
-                <a:spcPts val="800"/>
+                <a:spcPts val="1000"/>
               </a:spcAft>
-              <a:defRPr sz="1050">
-                <a:solidFill>
-                  <a:srgbClr val="1E293B"/>
-                </a:solidFill>
-                <a:latin typeface="Calibri"/>
-              </a:defRPr>
-            </a:pPr>
-            <a:r>
-              <a:t>   Estrés constante y sobrecarga mental por no tener confirmación de que la medicación se ha tomado.</a:t>
+              <a:defRPr sz="1100">
+                <a:solidFill>
+                  <a:srgbClr val="232F3E"/>
+                </a:solidFill>
+                <a:latin typeface="Calibri"/>
+              </a:defRPr>
+            </a:pPr>
+            <a:r>
+              <a:t>   Viven con la preocupación y el estrés diario de tener que estar comprobando si se han tomado la medicación.</a:t>
             </a:r>
           </a:p>
           <a:p>
@@ -3675,55 +3643,23 @@
               </a:defRPr>
             </a:pPr>
             <a:r>
-              <a:t>• Personas con Traumatismos o Dolor Físico: </a:t>
+              <a:t>• Personas con Lesiones Musculares o Dolor: </a:t>
             </a:r>
           </a:p>
           <a:p>
             <a:pPr>
               <a:spcAft>
-                <a:spcPts val="800"/>
+                <a:spcPts val="1000"/>
               </a:spcAft>
-              <a:defRPr sz="1050">
-                <a:solidFill>
-                  <a:srgbClr val="1E293B"/>
-                </a:solidFill>
-                <a:latin typeface="Calibri"/>
-              </a:defRPr>
-            </a:pPr>
-            <a:r>
-              <a:t>   Pacientes en recuperación de lesiones o con dolores de espalda/cuello que necesitan fortalecer zonas específicas.</a:t>
-            </a:r>
-          </a:p>
-          <a:p>
-            <a:pPr>
-              <a:spcAft>
-                <a:spcPts val="100"/>
-              </a:spcAft>
-              <a:defRPr sz="1200" b="1">
-                <a:solidFill>
-                  <a:srgbClr val="050C26"/>
-                </a:solidFill>
-                <a:latin typeface="Calibri"/>
-              </a:defRPr>
-            </a:pPr>
-            <a:r>
-              <a:t>• Sistema de Salud y ODS 3: </a:t>
-            </a:r>
-          </a:p>
-          <a:p>
-            <a:pPr>
-              <a:spcAft>
-                <a:spcPts val="800"/>
-              </a:spcAft>
-              <a:defRPr sz="1050">
-                <a:solidFill>
-                  <a:srgbClr val="1E293B"/>
-                </a:solidFill>
-                <a:latin typeface="Calibri"/>
-              </a:defRPr>
-            </a:pPr>
-            <a:r>
-              <a:t>   El mal uso de medicamentos colapsa consultas. Resolverlo impacta en el ODS 3 (Salud) y ODS 10 (Accesibilidad).</a:t>
+              <a:defRPr sz="1100">
+                <a:solidFill>
+                  <a:srgbClr val="232F3E"/>
+                </a:solidFill>
+                <a:latin typeface="Calibri"/>
+              </a:defRPr>
+            </a:pPr>
+            <a:r>
+              <a:t>   Pacientes en recuperación de traumatismos, contracturas o con dolores de espalda que necesitan guías de ejercicios.</a:t>
             </a:r>
           </a:p>
         </p:txBody>
@@ -3770,7 +3706,7 @@
           <a:lstStyle/>
           <a:p>
             <a:pPr algn="ctr">
-              <a:defRPr sz="1050" b="1">
+              <a:defRPr sz="1100" b="1">
                 <a:solidFill>
                   <a:srgbClr val="FFFFFF"/>
                 </a:solidFill>
@@ -3778,7 +3714,7 @@
               </a:defRPr>
             </a:pPr>
             <a:r>
-              <a:t>💡 IMPACTO: Alineado con los Objetivos de Desarrollo Sostenible (ODS 3 Salud y Bienestar • ODS 10 Reducción de Desigualdades)</a:t>
+              <a:t>💡 IMPACTO: Alineado con ODS 3 (Salud y Bienestar) y ODS 10 (Reducción de las Desigualdades)</a:t>
             </a:r>
           </a:p>
         </p:txBody>
@@ -3861,11 +3797,11 @@
             <a:avLst/>
           </a:prstGeom>
           <a:solidFill>
-            <a:srgbClr val="00D2B4"/>
+            <a:srgbClr val="00B496"/>
           </a:solidFill>
           <a:ln>
             <a:solidFill>
-              <a:srgbClr val="00D2B4"/>
+              <a:srgbClr val="00B496"/>
             </a:solidFill>
           </a:ln>
         </p:spPr>
@@ -3916,7 +3852,7 @@
             <a:pPr>
               <a:defRPr sz="1200" b="1">
                 <a:solidFill>
-                  <a:srgbClr val="00D2B4"/>
+                  <a:srgbClr val="00B496"/>
                 </a:solidFill>
                 <a:latin typeface="Calibri"/>
               </a:defRPr>
@@ -3997,7 +3933,7 @@
               </a:defRPr>
             </a:pPr>
             <a:r>
-              <a:t>2. Memorix: Solución Digital Accesible</a:t>
+              <a:t>2. Memorix: Propuesta Digital y Funcionalidades</a:t>
             </a:r>
           </a:p>
           <a:p>
@@ -4010,7 +3946,7 @@
               </a:defRPr>
             </a:pPr>
             <a:r>
-              <a:t>Asistente móvil inteligente con alto contraste visual para medicación y rehabilitación</a:t>
+              <a:t>Asistente móvil accesible para el control de medicamentos y ejercicios de recuperación</a:t>
             </a:r>
           </a:p>
         </p:txBody>
@@ -4118,7 +4054,7 @@
               </a:defRPr>
             </a:pPr>
             <a:r>
-              <a:t>⚡ FUNCIONALIDADES CLAVE DE MEMORIX</a:t>
+              <a:t>⚡ FUNCIONALIDADES CLAVE</a:t>
             </a:r>
           </a:p>
           <a:p>
@@ -4126,31 +4062,31 @@
               <a:spcAft>
                 <a:spcPts val="100"/>
               </a:spcAft>
-              <a:defRPr sz="1100" b="1">
-                <a:solidFill>
-                  <a:srgbClr val="00D2B4"/>
-                </a:solidFill>
-                <a:latin typeface="Calibri"/>
-              </a:defRPr>
-            </a:pPr>
-            <a:r>
-              <a:t>🔊 Alarmas Inteligentes con Audio-Guía</a:t>
+              <a:defRPr sz="1150" b="1">
+                <a:solidFill>
+                  <a:srgbClr val="00B496"/>
+                </a:solidFill>
+                <a:latin typeface="Calibri"/>
+              </a:defRPr>
+            </a:pPr>
+            <a:r>
+              <a:t>🔊 Alarmas con Locución por Voz</a:t>
             </a:r>
           </a:p>
           <a:p>
             <a:pPr>
               <a:spcAft>
-                <a:spcPts val="600"/>
+                <a:spcPts val="700"/>
               </a:spcAft>
-              <a:defRPr sz="950">
-                <a:solidFill>
-                  <a:srgbClr val="1E293B"/>
-                </a:solidFill>
-                <a:latin typeface="Calibri"/>
-              </a:defRPr>
-            </a:pPr>
-            <a:r>
-              <a:t>Reproduce por voz el nombre del fármaco, dosis e indicaciones (ej. 'tomar con agua tras la comida').</a:t>
+              <a:defRPr sz="1000">
+                <a:solidFill>
+                  <a:srgbClr val="232F3E"/>
+                </a:solidFill>
+                <a:latin typeface="Calibri"/>
+              </a:defRPr>
+            </a:pPr>
+            <a:r>
+              <a:t>Lee en voz alta el nombre de la pastilla, la dosis y cómo tomarla (ej. con comida).</a:t>
             </a:r>
           </a:p>
           <a:p>
@@ -4158,31 +4094,31 @@
               <a:spcAft>
                 <a:spcPts val="100"/>
               </a:spcAft>
-              <a:defRPr sz="1100" b="1">
-                <a:solidFill>
-                  <a:srgbClr val="00D2B4"/>
-                </a:solidFill>
-                <a:latin typeface="Calibri"/>
-              </a:defRPr>
-            </a:pPr>
-            <a:r>
-              <a:t>✅ Confirmación Fácil de Un Toque</a:t>
+              <a:defRPr sz="1150" b="1">
+                <a:solidFill>
+                  <a:srgbClr val="00B496"/>
+                </a:solidFill>
+                <a:latin typeface="Calibri"/>
+              </a:defRPr>
+            </a:pPr>
+            <a:r>
+              <a:t>👆 Confirmación Fácil de Un Toque</a:t>
             </a:r>
           </a:p>
           <a:p>
             <a:pPr>
               <a:spcAft>
-                <a:spcPts val="600"/>
+                <a:spcPts val="700"/>
               </a:spcAft>
-              <a:defRPr sz="950">
-                <a:solidFill>
-                  <a:srgbClr val="1E293B"/>
-                </a:solidFill>
-                <a:latin typeface="Calibri"/>
-              </a:defRPr>
-            </a:pPr>
-            <a:r>
-              <a:t>Botón táctil de gran visibilidad para registrar la toma y evitar duplicidades por despistes.</a:t>
+              <a:defRPr sz="1000">
+                <a:solidFill>
+                  <a:srgbClr val="232F3E"/>
+                </a:solidFill>
+                <a:latin typeface="Calibri"/>
+              </a:defRPr>
+            </a:pPr>
+            <a:r>
+              <a:t>Botón táctil grande para registrar la toma y evitar tomar la pastilla dos veces por despiste.</a:t>
             </a:r>
           </a:p>
           <a:p>
@@ -4190,31 +4126,31 @@
               <a:spcAft>
                 <a:spcPts val="100"/>
               </a:spcAft>
-              <a:defRPr sz="1100" b="1">
-                <a:solidFill>
-                  <a:srgbClr val="00D2B4"/>
-                </a:solidFill>
-                <a:latin typeface="Calibri"/>
-              </a:defRPr>
-            </a:pPr>
-            <a:r>
-              <a:t>🛡️ Alerta Automática SOS a Cuidadores</a:t>
+              <a:defRPr sz="1150" b="1">
+                <a:solidFill>
+                  <a:srgbClr val="00B496"/>
+                </a:solidFill>
+                <a:latin typeface="Calibri"/>
+              </a:defRPr>
+            </a:pPr>
+            <a:r>
+              <a:t>🛡️ Aviso Automático al Cuidador</a:t>
             </a:r>
           </a:p>
           <a:p>
             <a:pPr>
               <a:spcAft>
-                <a:spcPts val="600"/>
+                <a:spcPts val="700"/>
               </a:spcAft>
-              <a:defRPr sz="950">
-                <a:solidFill>
-                  <a:srgbClr val="1E293B"/>
-                </a:solidFill>
-                <a:latin typeface="Calibri"/>
-              </a:defRPr>
-            </a:pPr>
-            <a:r>
-              <a:t>Si tras 20 min no se confirma una toma crítica, envía aviso inmediato al familiar asignado.</a:t>
+              <a:defRPr sz="1000">
+                <a:solidFill>
+                  <a:srgbClr val="232F3E"/>
+                </a:solidFill>
+                <a:latin typeface="Calibri"/>
+              </a:defRPr>
+            </a:pPr>
+            <a:r>
+              <a:t>Manda una alerta al móvil del familiar si pasan 20 minutos sin confirmarse la toma.</a:t>
             </a:r>
           </a:p>
           <a:p>
@@ -4222,31 +4158,31 @@
               <a:spcAft>
                 <a:spcPts val="100"/>
               </a:spcAft>
-              <a:defRPr sz="1100" b="1">
-                <a:solidFill>
-                  <a:srgbClr val="00D2B4"/>
-                </a:solidFill>
-                <a:latin typeface="Calibri"/>
-              </a:defRPr>
-            </a:pPr>
-            <a:r>
-              <a:t>🏋️ Rutinas de Fortalecimiento Muscular</a:t>
+              <a:defRPr sz="1150" b="1">
+                <a:solidFill>
+                  <a:srgbClr val="00B496"/>
+                </a:solidFill>
+                <a:latin typeface="Calibri"/>
+              </a:defRPr>
+            </a:pPr>
+            <a:r>
+              <a:t>🏋️ Ejercicios Musculares Guiados</a:t>
             </a:r>
           </a:p>
           <a:p>
             <a:pPr>
               <a:spcAft>
-                <a:spcPts val="600"/>
+                <a:spcPts val="700"/>
               </a:spcAft>
-              <a:defRPr sz="950">
-                <a:solidFill>
-                  <a:srgbClr val="1E293B"/>
-                </a:solidFill>
-                <a:latin typeface="Calibri"/>
-              </a:defRPr>
-            </a:pPr>
-            <a:r>
-              <a:t>Ejercicios guiados paso a paso con temporizador para dolores de espalda, hombros, cuello o piernas.</a:t>
+              <a:defRPr sz="1000">
+                <a:solidFill>
+                  <a:srgbClr val="232F3E"/>
+                </a:solidFill>
+                <a:latin typeface="Calibri"/>
+              </a:defRPr>
+            </a:pPr>
+            <a:r>
+              <a:t>Rutinas para dolores o traumatismos con temporizador, series y descansos en pantalla.</a:t>
             </a:r>
           </a:p>
           <a:p>
@@ -4254,63 +4190,31 @@
               <a:spcAft>
                 <a:spcPts val="100"/>
               </a:spcAft>
-              <a:defRPr sz="1100" b="1">
-                <a:solidFill>
-                  <a:srgbClr val="00D2B4"/>
-                </a:solidFill>
-                <a:latin typeface="Calibri"/>
-              </a:defRPr>
-            </a:pPr>
-            <a:r>
-              <a:t>🎨 Interfaz de Alto Contraste (Modo Senior)</a:t>
+              <a:defRPr sz="1150" b="1">
+                <a:solidFill>
+                  <a:srgbClr val="00B496"/>
+                </a:solidFill>
+                <a:latin typeface="Calibri"/>
+              </a:defRPr>
+            </a:pPr>
+            <a:r>
+              <a:t>🎨 Interfaz de Alto Contraste</a:t>
             </a:r>
           </a:p>
           <a:p>
             <a:pPr>
               <a:spcAft>
-                <a:spcPts val="600"/>
+                <a:spcPts val="700"/>
               </a:spcAft>
-              <a:defRPr sz="950">
-                <a:solidFill>
-                  <a:srgbClr val="1E293B"/>
-                </a:solidFill>
-                <a:latin typeface="Calibri"/>
-              </a:defRPr>
-            </a:pPr>
-            <a:r>
-              <a:t>Gama cromática de máxima legibilidad (azul, cian, menta) adaptada a problemas visuales.</a:t>
-            </a:r>
-          </a:p>
-          <a:p>
-            <a:pPr>
-              <a:spcAft>
-                <a:spcPts val="100"/>
-              </a:spcAft>
-              <a:defRPr sz="1100" b="1">
-                <a:solidFill>
-                  <a:srgbClr val="00D2B4"/>
-                </a:solidFill>
-                <a:latin typeface="Calibri"/>
-              </a:defRPr>
-            </a:pPr>
-            <a:r>
-              <a:t>📊 Historial de Adherencia Exportable</a:t>
-            </a:r>
-          </a:p>
-          <a:p>
-            <a:pPr>
-              <a:spcAft>
-                <a:spcPts val="600"/>
-              </a:spcAft>
-              <a:defRPr sz="950">
-                <a:solidFill>
-                  <a:srgbClr val="1E293B"/>
-                </a:solidFill>
-                <a:latin typeface="Calibri"/>
-              </a:defRPr>
-            </a:pPr>
-            <a:r>
-              <a:t>Estadísticas semanales y mensuales de cumplimiento listas para compartir con el médico.</a:t>
+              <a:defRPr sz="1000">
+                <a:solidFill>
+                  <a:srgbClr val="232F3E"/>
+                </a:solidFill>
+                <a:latin typeface="Calibri"/>
+              </a:defRPr>
+            </a:pPr>
+            <a:r>
+              <a:t>Tipografía clara y colores contrastados pensados para personas mayores o con poca vista.</a:t>
             </a:r>
           </a:p>
         </p:txBody>
@@ -4357,7 +4261,7 @@
           <a:lstStyle/>
           <a:p>
             <a:pPr algn="ctr">
-              <a:defRPr sz="1050" b="1">
+              <a:defRPr sz="1100" b="1">
                 <a:solidFill>
                   <a:srgbClr val="FFFFFF"/>
                 </a:solidFill>
@@ -4365,7 +4269,7 @@
               </a:defRPr>
             </a:pPr>
             <a:r>
-              <a:t>📱 Memorix: Aplicación Multiplataforma (Android / iOS) • Enfoque Universal y Accesible</a:t>
+              <a:t>📱 Solución Multiplataforma (Android / iOS) • Modo Fácil Diseñado para la Tercera Edad</a:t>
             </a:r>
           </a:p>
         </p:txBody>
@@ -4448,11 +4352,11 @@
             <a:avLst/>
           </a:prstGeom>
           <a:solidFill>
-            <a:srgbClr val="00D2B4"/>
+            <a:srgbClr val="00B496"/>
           </a:solidFill>
           <a:ln>
             <a:solidFill>
-              <a:srgbClr val="00D2B4"/>
+              <a:srgbClr val="00B496"/>
             </a:solidFill>
           </a:ln>
         </p:spPr>
@@ -4503,7 +4407,7 @@
             <a:pPr>
               <a:defRPr sz="1200" b="1">
                 <a:solidFill>
-                  <a:srgbClr val="00D2B4"/>
+                  <a:srgbClr val="00B496"/>
                 </a:solidFill>
                 <a:latin typeface="Calibri"/>
               </a:defRPr>
@@ -4584,7 +4488,7 @@
               </a:defRPr>
             </a:pPr>
             <a:r>
-              <a:t>3. Valor Añadido y Visión de Futuro</a:t>
+              <a:t>3. Valor Diferencial y Mejoras Futuras</a:t>
             </a:r>
           </a:p>
           <a:p>
@@ -4597,7 +4501,7 @@
               </a:defRPr>
             </a:pPr>
             <a:r>
-              <a:t>¿Por qué Memorix marca la diferencia y hacia dónde evoluciona?</a:t>
+              <a:t>¿Por qué resulta útil esta solución y cómo puede evolucionar?</a:t>
             </a:r>
           </a:p>
         </p:txBody>
@@ -4675,13 +4579,13 @@
               </a:spcAft>
               <a:defRPr sz="1500" b="1">
                 <a:solidFill>
-                  <a:srgbClr val="00D2B4"/>
-                </a:solidFill>
-                <a:latin typeface="Calibri"/>
-              </a:defRPr>
-            </a:pPr>
-            <a:r>
-              <a:t>🌟 VALOR AÑADIDO DIFERENCIAL</a:t>
+                  <a:srgbClr val="00B496"/>
+                </a:solidFill>
+                <a:latin typeface="Calibri"/>
+              </a:defRPr>
+            </a:pPr>
+            <a:r>
+              <a:t>🌟 VALOR AÑADIDO (¿POR QUÉ ES ÚTIL?)</a:t>
             </a:r>
           </a:p>
           <a:p>
@@ -4697,7 +4601,7 @@
               </a:defRPr>
             </a:pPr>
             <a:r>
-              <a:t>✔ Doble Enfoque Integral (Fármacos + Fisioterapia): </a:t>
+              <a:t>✔ Solución 2 en 1 (Medicamentos + Ejercicio): </a:t>
             </a:r>
           </a:p>
           <a:p>
@@ -4705,15 +4609,15 @@
               <a:spcAft>
                 <a:spcPts val="800"/>
               </a:spcAft>
-              <a:defRPr sz="1050">
-                <a:solidFill>
-                  <a:srgbClr val="1E293B"/>
-                </a:solidFill>
-                <a:latin typeface="Calibri"/>
-              </a:defRPr>
-            </a:pPr>
-            <a:r>
-              <a:t>   Unifica en un solo lugar la adherencia médica y la actividad física terapéutica.</a:t>
+              <a:defRPr sz="1000">
+                <a:solidFill>
+                  <a:srgbClr val="232F3E"/>
+                </a:solidFill>
+                <a:latin typeface="Calibri"/>
+              </a:defRPr>
+            </a:pPr>
+            <a:r>
+              <a:t>   Une en una sola aplicación el control de los tratamientos y la recuperación física activa.</a:t>
             </a:r>
           </a:p>
           <a:p>
@@ -4729,7 +4633,7 @@
               </a:defRPr>
             </a:pPr>
             <a:r>
-              <a:t>✔ Accesibilidad Total por Contrastes: </a:t>
+              <a:t>✔ Mayor Autonomía para Personas Mayores: </a:t>
             </a:r>
           </a:p>
           <a:p>
@@ -4737,15 +4641,15 @@
               <a:spcAft>
                 <a:spcPts val="800"/>
               </a:spcAft>
-              <a:defRPr sz="1050">
-                <a:solidFill>
-                  <a:srgbClr val="1E293B"/>
-                </a:solidFill>
-                <a:latin typeface="Calibri"/>
-              </a:defRPr>
-            </a:pPr>
-            <a:r>
-              <a:t>   La identidad gráfica de Memorix utiliza contrastes cromáticos de grado médico para eliminar barreras cognitivas.</a:t>
+              <a:defRPr sz="1000">
+                <a:solidFill>
+                  <a:srgbClr val="232F3E"/>
+                </a:solidFill>
+                <a:latin typeface="Calibri"/>
+              </a:defRPr>
+            </a:pPr>
+            <a:r>
+              <a:t>   Las explicaciones por voz y los botones grandes permiten manejarse sin depender siempre de otra persona.</a:t>
             </a:r>
           </a:p>
           <a:p>
@@ -4761,7 +4665,7 @@
               </a:defRPr>
             </a:pPr>
             <a:r>
-              <a:t>✔ Autonomía Real para la Tercera Edad: </a:t>
+              <a:t>✔ Tranquilidad para los Familiares: </a:t>
             </a:r>
           </a:p>
           <a:p>
@@ -4769,15 +4673,15 @@
               <a:spcAft>
                 <a:spcPts val="800"/>
               </a:spcAft>
-              <a:defRPr sz="1050">
-                <a:solidFill>
-                  <a:srgbClr val="1E293B"/>
-                </a:solidFill>
-                <a:latin typeface="Calibri"/>
-              </a:defRPr>
-            </a:pPr>
-            <a:r>
-              <a:t>   Instrucciones de audio claras y botones gigantes que devuelven la independencia al paciente.</a:t>
+              <a:defRPr sz="1000">
+                <a:solidFill>
+                  <a:srgbClr val="232F3E"/>
+                </a:solidFill>
+                <a:latin typeface="Calibri"/>
+              </a:defRPr>
+            </a:pPr>
+            <a:r>
+              <a:t>   Supervisión sin agobios; solo reciben alerta en el móvil si su familiar no confirma una toma.</a:t>
             </a:r>
           </a:p>
           <a:p>
@@ -4793,7 +4697,7 @@
               </a:defRPr>
             </a:pPr>
             <a:r>
-              <a:t>✔ Paz Mental para las Familias: </a:t>
+              <a:t>✔ Constancia en la Rehabilitación: </a:t>
             </a:r>
           </a:p>
           <a:p>
@@ -4801,15 +4705,15 @@
               <a:spcAft>
                 <a:spcPts val="800"/>
               </a:spcAft>
-              <a:defRPr sz="1050">
-                <a:solidFill>
-                  <a:srgbClr val="1E293B"/>
-                </a:solidFill>
-                <a:latin typeface="Calibri"/>
-              </a:defRPr>
-            </a:pPr>
-            <a:r>
-              <a:t>   Supervisión remota pasiva: solo alerta a los familiares cuando realmente ocurre una omisión.</a:t>
+              <a:defRPr sz="1000">
+                <a:solidFill>
+                  <a:srgbClr val="232F3E"/>
+                </a:solidFill>
+                <a:latin typeface="Calibri"/>
+              </a:defRPr>
+            </a:pPr>
+            <a:r>
+              <a:t>   Las guías visuales con cronómetro ayudan a no abandonar los ejercicios musculares en casa.</a:t>
             </a:r>
           </a:p>
         </p:txBody>
@@ -4893,7 +4797,7 @@
               </a:defRPr>
             </a:pPr>
             <a:r>
-              <a:t>🚀 MEJORAS FUTURAS DE MEMORIX</a:t>
+              <a:t>🚀 MEJORAS FUTURAS PREVISTAS</a:t>
             </a:r>
           </a:p>
           <a:p>
@@ -4909,7 +4813,7 @@
               </a:defRPr>
             </a:pPr>
             <a:r>
-              <a:t>✦ IA de Visión Artificial (Computer Vision): </a:t>
+              <a:t>✦ Visión Artificial con Cámara Móvil: </a:t>
             </a:r>
           </a:p>
           <a:p>
@@ -4917,15 +4821,15 @@
               <a:spcAft>
                 <a:spcPts val="800"/>
               </a:spcAft>
-              <a:defRPr sz="1050">
-                <a:solidFill>
-                  <a:srgbClr val="1E293B"/>
-                </a:solidFill>
-                <a:latin typeface="Calibri"/>
-              </a:defRPr>
-            </a:pPr>
-            <a:r>
-              <a:t>   Supervisión postural en tiempo real a través de la cámara del móvil durante los ejercicios de fisioterapia.</a:t>
+              <a:defRPr sz="1000">
+                <a:solidFill>
+                  <a:srgbClr val="232F3E"/>
+                </a:solidFill>
+                <a:latin typeface="Calibri"/>
+              </a:defRPr>
+            </a:pPr>
+            <a:r>
+              <a:t>   Detección de la postura del usuario en tiempo real durante los ejercicios para avisar por voz si la espalda está mal colocada.</a:t>
             </a:r>
           </a:p>
           <a:p>
@@ -4941,7 +4845,7 @@
               </a:defRPr>
             </a:pPr>
             <a:r>
-              <a:t>✦ Escaneo OCR Inteligente de Cajas: </a:t>
+              <a:t>✦ Conexión con Pulseras Inteligentes (Smartwatch): </a:t>
             </a:r>
           </a:p>
           <a:p>
@@ -4949,15 +4853,15 @@
               <a:spcAft>
                 <a:spcPts val="800"/>
               </a:spcAft>
-              <a:defRPr sz="1050">
-                <a:solidFill>
-                  <a:srgbClr val="1E293B"/>
-                </a:solidFill>
-                <a:latin typeface="Calibri"/>
-              </a:defRPr>
-            </a:pPr>
-            <a:r>
-              <a:t>   Reconocimiento automático de prospectos y posología con solo enfocar la caja del medicamento.</a:t>
+              <a:defRPr sz="1000">
+                <a:solidFill>
+                  <a:srgbClr val="232F3E"/>
+                </a:solidFill>
+                <a:latin typeface="Calibri"/>
+              </a:defRPr>
+            </a:pPr>
+            <a:r>
+              <a:t>   Avisos de medicación por vibración en la muñeca y detección de caídas accidentales en ancianos.</a:t>
             </a:r>
           </a:p>
           <a:p>
@@ -4973,7 +4877,7 @@
               </a:defRPr>
             </a:pPr>
             <a:r>
-              <a:t>✦ Conectividad IoT con Smartwatches: </a:t>
+              <a:t>✦ Escaneo de Cajas de Medicamentos: </a:t>
             </a:r>
           </a:p>
           <a:p>
@@ -4981,47 +4885,15 @@
               <a:spcAft>
                 <a:spcPts val="800"/>
               </a:spcAft>
-              <a:defRPr sz="1050">
-                <a:solidFill>
-                  <a:srgbClr val="1E293B"/>
-                </a:solidFill>
-                <a:latin typeface="Calibri"/>
-              </a:defRPr>
-            </a:pPr>
-            <a:r>
-              <a:t>   Vibración en la muñeca para avisar de la toma y detección de caídas en personas mayores.</a:t>
-            </a:r>
-          </a:p>
-          <a:p>
-            <a:pPr>
-              <a:spcAft>
-                <a:spcPts val="100"/>
-              </a:spcAft>
-              <a:defRPr sz="1150" b="1">
-                <a:solidFill>
-                  <a:srgbClr val="050C26"/>
-                </a:solidFill>
-                <a:latin typeface="Calibri"/>
-              </a:defRPr>
-            </a:pPr>
-            <a:r>
-              <a:t>✦ Interoperabilidad con Receta Electrónica: </a:t>
-            </a:r>
-          </a:p>
-          <a:p>
-            <a:pPr>
-              <a:spcAft>
-                <a:spcPts val="800"/>
-              </a:spcAft>
-              <a:defRPr sz="1050">
-                <a:solidFill>
-                  <a:srgbClr val="1E293B"/>
-                </a:solidFill>
-                <a:latin typeface="Calibri"/>
-              </a:defRPr>
-            </a:pPr>
-            <a:r>
-              <a:t>   Conexión directa con la historia clínica pública para actualizar dosis automáticamente.</a:t>
+              <a:defRPr sz="1000">
+                <a:solidFill>
+                  <a:srgbClr val="232F3E"/>
+                </a:solidFill>
+                <a:latin typeface="Calibri"/>
+              </a:defRPr>
+            </a:pPr>
+            <a:r>
+              <a:t>   Reconocimiento automático de la pastilla con la cámara para añadir la alarma sin tener que escribir.</a:t>
             </a:r>
           </a:p>
         </p:txBody>
@@ -5068,7 +4940,7 @@
           <a:lstStyle/>
           <a:p>
             <a:pPr algn="ctr">
-              <a:defRPr sz="1050" b="1">
+              <a:defRPr sz="1100" b="1">
                 <a:solidFill>
                   <a:srgbClr val="FFFFFF"/>
                 </a:solidFill>
@@ -5076,7 +4948,7 @@
               </a:defRPr>
             </a:pPr>
             <a:r>
-              <a:t>🎯 MEMORIX: Tecnología accesible al servicio de la salud, autonomía y bienestar de las personas</a:t>
+              <a:t>🎯 MEMORIX  •  Proyecto Intermodular 2º DAM  •  Kevin Muñoz Córcoles</a:t>
             </a:r>
           </a:p>
         </p:txBody>

</xml_diff>

<commit_message>
Ultimos cambios del proyecto
arreglos de ultima hora
</commit_message>
<xml_diff>
--- a/Proyecto intermodular/UD1/Tarea0-2DAM/Tarea0_Memorix_Presentacion.pptx
+++ b/Proyecto intermodular/UD1/Tarea0-2DAM/Tarea0_Memorix_Presentacion.pptx
@@ -5,11 +5,11 @@
     <p:sldMasterId id="2147483648" r:id="rId1"/>
   </p:sldMasterIdLst>
   <p:sldIdLst>
-    <p:sldId id="256" r:id="rId7"/>
-    <p:sldId id="257" r:id="rId8"/>
-    <p:sldId id="258" r:id="rId9"/>
+    <p:sldId id="256" r:id="rId2"/>
+    <p:sldId id="257" r:id="rId3"/>
+    <p:sldId id="258" r:id="rId4"/>
   </p:sldIdLst>
-  <p:sldSz cx="12191695" cy="6858000" type="screen4x3"/>
+  <p:sldSz cx="12192000" cy="6858000"/>
   <p:notesSz cx="6858000" cy="9144000"/>
   <p:defaultTextStyle>
     <a:defPPr>
@@ -106,6 +106,22 @@
       </a:defRPr>
     </a:lvl9pPr>
   </p:defaultTextStyle>
+  <p:extLst>
+    <p:ext uri="{EFAFB233-063F-42B5-8137-9DF3F51BA10A}">
+      <p15:sldGuideLst xmlns:p15="http://schemas.microsoft.com/office/powerpoint/2012/main">
+        <p15:guide id="1" orient="horz" pos="2160">
+          <p15:clr>
+            <a:srgbClr val="A4A3A4"/>
+          </p15:clr>
+        </p15:guide>
+        <p15:guide id="2" pos="2880">
+          <p15:clr>
+            <a:srgbClr val="A4A3A4"/>
+          </p15:clr>
+        </p15:guide>
+      </p15:sldGuideLst>
+    </p:ext>
+  </p:extLst>
 </p:presentation>
 </file>
 
@@ -147,10 +163,9 @@
           <a:lstStyle/>
           <a:p>
             <a:r>
-              <a:rPr lang="en-US" smtClean="0"/>
+              <a:rPr lang="en-US"/>
               <a:t>Click to edit Master title style</a:t>
             </a:r>
-            <a:endParaRPr lang="en-US"/>
           </a:p>
         </p:txBody>
       </p:sp>
@@ -266,10 +281,9 @@
           </a:lstStyle>
           <a:p>
             <a:r>
-              <a:rPr lang="en-US" smtClean="0"/>
+              <a:rPr lang="en-US"/>
               <a:t>Click to edit Master subtitle style</a:t>
             </a:r>
-            <a:endParaRPr lang="en-US"/>
           </a:p>
         </p:txBody>
       </p:sp>
@@ -290,7 +304,7 @@
           <a:p>
             <a:fld id="{5BCAD085-E8A6-8845-BD4E-CB4CCA059FC4}" type="datetimeFigureOut">
               <a:rPr lang="en-US" smtClean="0"/>
-              <a:t>1/27/13</a:t>
+              <a:t>9/29/2026</a:t>
             </a:fld>
             <a:endParaRPr lang="en-US"/>
           </a:p>
@@ -384,10 +398,9 @@
           <a:lstStyle/>
           <a:p>
             <a:r>
-              <a:rPr lang="en-US" smtClean="0"/>
+              <a:rPr lang="en-US"/>
               <a:t>Click to edit Master title style</a:t>
             </a:r>
-            <a:endParaRPr lang="en-US"/>
           </a:p>
         </p:txBody>
       </p:sp>
@@ -408,38 +421,37 @@
           <a:p>
             <a:pPr lvl="0"/>
             <a:r>
-              <a:rPr lang="en-US" smtClean="0"/>
+              <a:rPr lang="en-US"/>
               <a:t>Click to edit Master text styles</a:t>
             </a:r>
           </a:p>
           <a:p>
             <a:pPr lvl="1"/>
             <a:r>
-              <a:rPr lang="en-US" smtClean="0"/>
+              <a:rPr lang="en-US"/>
               <a:t>Second level</a:t>
             </a:r>
           </a:p>
           <a:p>
             <a:pPr lvl="2"/>
             <a:r>
-              <a:rPr lang="en-US" smtClean="0"/>
+              <a:rPr lang="en-US"/>
               <a:t>Third level</a:t>
             </a:r>
           </a:p>
           <a:p>
             <a:pPr lvl="3"/>
             <a:r>
-              <a:rPr lang="en-US" smtClean="0"/>
+              <a:rPr lang="en-US"/>
               <a:t>Fourth level</a:t>
             </a:r>
           </a:p>
           <a:p>
             <a:pPr lvl="4"/>
             <a:r>
-              <a:rPr lang="en-US" smtClean="0"/>
+              <a:rPr lang="en-US"/>
               <a:t>Fifth level</a:t>
             </a:r>
-            <a:endParaRPr lang="en-US"/>
           </a:p>
         </p:txBody>
       </p:sp>
@@ -460,7 +472,7 @@
           <a:p>
             <a:fld id="{5BCAD085-E8A6-8845-BD4E-CB4CCA059FC4}" type="datetimeFigureOut">
               <a:rPr lang="en-US" smtClean="0"/>
-              <a:t>1/27/13</a:t>
+              <a:t>9/29/2026</a:t>
             </a:fld>
             <a:endParaRPr lang="en-US"/>
           </a:p>
@@ -559,10 +571,9 @@
           <a:lstStyle/>
           <a:p>
             <a:r>
-              <a:rPr lang="en-US" smtClean="0"/>
+              <a:rPr lang="en-US"/>
               <a:t>Click to edit Master title style</a:t>
             </a:r>
-            <a:endParaRPr lang="en-US"/>
           </a:p>
         </p:txBody>
       </p:sp>
@@ -588,38 +599,37 @@
           <a:p>
             <a:pPr lvl="0"/>
             <a:r>
-              <a:rPr lang="en-US" smtClean="0"/>
+              <a:rPr lang="en-US"/>
               <a:t>Click to edit Master text styles</a:t>
             </a:r>
           </a:p>
           <a:p>
             <a:pPr lvl="1"/>
             <a:r>
-              <a:rPr lang="en-US" smtClean="0"/>
+              <a:rPr lang="en-US"/>
               <a:t>Second level</a:t>
             </a:r>
           </a:p>
           <a:p>
             <a:pPr lvl="2"/>
             <a:r>
-              <a:rPr lang="en-US" smtClean="0"/>
+              <a:rPr lang="en-US"/>
               <a:t>Third level</a:t>
             </a:r>
           </a:p>
           <a:p>
             <a:pPr lvl="3"/>
             <a:r>
-              <a:rPr lang="en-US" smtClean="0"/>
+              <a:rPr lang="en-US"/>
               <a:t>Fourth level</a:t>
             </a:r>
           </a:p>
           <a:p>
             <a:pPr lvl="4"/>
             <a:r>
-              <a:rPr lang="en-US" smtClean="0"/>
+              <a:rPr lang="en-US"/>
               <a:t>Fifth level</a:t>
             </a:r>
-            <a:endParaRPr lang="en-US"/>
           </a:p>
         </p:txBody>
       </p:sp>
@@ -640,7 +650,7 @@
           <a:p>
             <a:fld id="{5BCAD085-E8A6-8845-BD4E-CB4CCA059FC4}" type="datetimeFigureOut">
               <a:rPr lang="en-US" smtClean="0"/>
-              <a:t>1/27/13</a:t>
+              <a:t>9/29/2026</a:t>
             </a:fld>
             <a:endParaRPr lang="en-US"/>
           </a:p>
@@ -734,10 +744,9 @@
           <a:lstStyle/>
           <a:p>
             <a:r>
-              <a:rPr lang="en-US" smtClean="0"/>
+              <a:rPr lang="en-US"/>
               <a:t>Click to edit Master title style</a:t>
             </a:r>
-            <a:endParaRPr lang="en-US"/>
           </a:p>
         </p:txBody>
       </p:sp>
@@ -758,38 +767,37 @@
           <a:p>
             <a:pPr lvl="0"/>
             <a:r>
-              <a:rPr lang="en-US" smtClean="0"/>
+              <a:rPr lang="en-US"/>
               <a:t>Click to edit Master text styles</a:t>
             </a:r>
           </a:p>
           <a:p>
             <a:pPr lvl="1"/>
             <a:r>
-              <a:rPr lang="en-US" smtClean="0"/>
+              <a:rPr lang="en-US"/>
               <a:t>Second level</a:t>
             </a:r>
           </a:p>
           <a:p>
             <a:pPr lvl="2"/>
             <a:r>
-              <a:rPr lang="en-US" smtClean="0"/>
+              <a:rPr lang="en-US"/>
               <a:t>Third level</a:t>
             </a:r>
           </a:p>
           <a:p>
             <a:pPr lvl="3"/>
             <a:r>
-              <a:rPr lang="en-US" smtClean="0"/>
+              <a:rPr lang="en-US"/>
               <a:t>Fourth level</a:t>
             </a:r>
           </a:p>
           <a:p>
             <a:pPr lvl="4"/>
             <a:r>
-              <a:rPr lang="en-US" smtClean="0"/>
+              <a:rPr lang="en-US"/>
               <a:t>Fifth level</a:t>
             </a:r>
-            <a:endParaRPr lang="en-US"/>
           </a:p>
         </p:txBody>
       </p:sp>
@@ -810,7 +818,7 @@
           <a:p>
             <a:fld id="{5BCAD085-E8A6-8845-BD4E-CB4CCA059FC4}" type="datetimeFigureOut">
               <a:rPr lang="en-US" smtClean="0"/>
-              <a:t>1/27/13</a:t>
+              <a:t>9/29/2026</a:t>
             </a:fld>
             <a:endParaRPr lang="en-US"/>
           </a:p>
@@ -913,10 +921,9 @@
           </a:lstStyle>
           <a:p>
             <a:r>
-              <a:rPr lang="en-US" smtClean="0"/>
+              <a:rPr lang="en-US"/>
               <a:t>Click to edit Master title style</a:t>
             </a:r>
-            <a:endParaRPr lang="en-US"/>
           </a:p>
         </p:txBody>
       </p:sp>
@@ -1033,7 +1040,7 @@
           <a:p>
             <a:pPr lvl="0"/>
             <a:r>
-              <a:rPr lang="en-US" smtClean="0"/>
+              <a:rPr lang="en-US"/>
               <a:t>Click to edit Master text styles</a:t>
             </a:r>
           </a:p>
@@ -1056,7 +1063,7 @@
           <a:p>
             <a:fld id="{5BCAD085-E8A6-8845-BD4E-CB4CCA059FC4}" type="datetimeFigureOut">
               <a:rPr lang="en-US" smtClean="0"/>
-              <a:t>1/27/13</a:t>
+              <a:t>9/29/2026</a:t>
             </a:fld>
             <a:endParaRPr lang="en-US"/>
           </a:p>
@@ -1150,10 +1157,9 @@
           <a:lstStyle/>
           <a:p>
             <a:r>
-              <a:rPr lang="en-US" smtClean="0"/>
+              <a:rPr lang="en-US"/>
               <a:t>Click to edit Master title style</a:t>
             </a:r>
-            <a:endParaRPr lang="en-US"/>
           </a:p>
         </p:txBody>
       </p:sp>
@@ -1207,38 +1213,37 @@
           <a:p>
             <a:pPr lvl="0"/>
             <a:r>
-              <a:rPr lang="en-US" smtClean="0"/>
+              <a:rPr lang="en-US"/>
               <a:t>Click to edit Master text styles</a:t>
             </a:r>
           </a:p>
           <a:p>
             <a:pPr lvl="1"/>
             <a:r>
-              <a:rPr lang="en-US" smtClean="0"/>
+              <a:rPr lang="en-US"/>
               <a:t>Second level</a:t>
             </a:r>
           </a:p>
           <a:p>
             <a:pPr lvl="2"/>
             <a:r>
-              <a:rPr lang="en-US" smtClean="0"/>
+              <a:rPr lang="en-US"/>
               <a:t>Third level</a:t>
             </a:r>
           </a:p>
           <a:p>
             <a:pPr lvl="3"/>
             <a:r>
-              <a:rPr lang="en-US" smtClean="0"/>
+              <a:rPr lang="en-US"/>
               <a:t>Fourth level</a:t>
             </a:r>
           </a:p>
           <a:p>
             <a:pPr lvl="4"/>
             <a:r>
-              <a:rPr lang="en-US" smtClean="0"/>
+              <a:rPr lang="en-US"/>
               <a:t>Fifth level</a:t>
             </a:r>
-            <a:endParaRPr lang="en-US"/>
           </a:p>
         </p:txBody>
       </p:sp>
@@ -1292,38 +1297,37 @@
           <a:p>
             <a:pPr lvl="0"/>
             <a:r>
-              <a:rPr lang="en-US" smtClean="0"/>
+              <a:rPr lang="en-US"/>
               <a:t>Click to edit Master text styles</a:t>
             </a:r>
           </a:p>
           <a:p>
             <a:pPr lvl="1"/>
             <a:r>
-              <a:rPr lang="en-US" smtClean="0"/>
+              <a:rPr lang="en-US"/>
               <a:t>Second level</a:t>
             </a:r>
           </a:p>
           <a:p>
             <a:pPr lvl="2"/>
             <a:r>
-              <a:rPr lang="en-US" smtClean="0"/>
+              <a:rPr lang="en-US"/>
               <a:t>Third level</a:t>
             </a:r>
           </a:p>
           <a:p>
             <a:pPr lvl="3"/>
             <a:r>
-              <a:rPr lang="en-US" smtClean="0"/>
+              <a:rPr lang="en-US"/>
               <a:t>Fourth level</a:t>
             </a:r>
           </a:p>
           <a:p>
             <a:pPr lvl="4"/>
             <a:r>
-              <a:rPr lang="en-US" smtClean="0"/>
+              <a:rPr lang="en-US"/>
               <a:t>Fifth level</a:t>
             </a:r>
-            <a:endParaRPr lang="en-US"/>
           </a:p>
         </p:txBody>
       </p:sp>
@@ -1344,7 +1348,7 @@
           <a:p>
             <a:fld id="{5BCAD085-E8A6-8845-BD4E-CB4CCA059FC4}" type="datetimeFigureOut">
               <a:rPr lang="en-US" smtClean="0"/>
-              <a:t>1/27/13</a:t>
+              <a:t>9/29/2026</a:t>
             </a:fld>
             <a:endParaRPr lang="en-US"/>
           </a:p>
@@ -1442,10 +1446,9 @@
           </a:lstStyle>
           <a:p>
             <a:r>
-              <a:rPr lang="en-US" smtClean="0"/>
+              <a:rPr lang="en-US"/>
               <a:t>Click to edit Master title style</a:t>
             </a:r>
-            <a:endParaRPr lang="en-US"/>
           </a:p>
         </p:txBody>
       </p:sp>
@@ -1508,7 +1511,7 @@
           <a:p>
             <a:pPr lvl="0"/>
             <a:r>
-              <a:rPr lang="en-US" smtClean="0"/>
+              <a:rPr lang="en-US"/>
               <a:t>Click to edit Master text styles</a:t>
             </a:r>
           </a:p>
@@ -1564,38 +1567,37 @@
           <a:p>
             <a:pPr lvl="0"/>
             <a:r>
-              <a:rPr lang="en-US" smtClean="0"/>
+              <a:rPr lang="en-US"/>
               <a:t>Click to edit Master text styles</a:t>
             </a:r>
           </a:p>
           <a:p>
             <a:pPr lvl="1"/>
             <a:r>
-              <a:rPr lang="en-US" smtClean="0"/>
+              <a:rPr lang="en-US"/>
               <a:t>Second level</a:t>
             </a:r>
           </a:p>
           <a:p>
             <a:pPr lvl="2"/>
             <a:r>
-              <a:rPr lang="en-US" smtClean="0"/>
+              <a:rPr lang="en-US"/>
               <a:t>Third level</a:t>
             </a:r>
           </a:p>
           <a:p>
             <a:pPr lvl="3"/>
             <a:r>
-              <a:rPr lang="en-US" smtClean="0"/>
+              <a:rPr lang="en-US"/>
               <a:t>Fourth level</a:t>
             </a:r>
           </a:p>
           <a:p>
             <a:pPr lvl="4"/>
             <a:r>
-              <a:rPr lang="en-US" smtClean="0"/>
+              <a:rPr lang="en-US"/>
               <a:t>Fifth level</a:t>
             </a:r>
-            <a:endParaRPr lang="en-US"/>
           </a:p>
         </p:txBody>
       </p:sp>
@@ -1658,7 +1660,7 @@
           <a:p>
             <a:pPr lvl="0"/>
             <a:r>
-              <a:rPr lang="en-US" smtClean="0"/>
+              <a:rPr lang="en-US"/>
               <a:t>Click to edit Master text styles</a:t>
             </a:r>
           </a:p>
@@ -1714,38 +1716,37 @@
           <a:p>
             <a:pPr lvl="0"/>
             <a:r>
-              <a:rPr lang="en-US" smtClean="0"/>
+              <a:rPr lang="en-US"/>
               <a:t>Click to edit Master text styles</a:t>
             </a:r>
           </a:p>
           <a:p>
             <a:pPr lvl="1"/>
             <a:r>
-              <a:rPr lang="en-US" smtClean="0"/>
+              <a:rPr lang="en-US"/>
               <a:t>Second level</a:t>
             </a:r>
           </a:p>
           <a:p>
             <a:pPr lvl="2"/>
             <a:r>
-              <a:rPr lang="en-US" smtClean="0"/>
+              <a:rPr lang="en-US"/>
               <a:t>Third level</a:t>
             </a:r>
           </a:p>
           <a:p>
             <a:pPr lvl="3"/>
             <a:r>
-              <a:rPr lang="en-US" smtClean="0"/>
+              <a:rPr lang="en-US"/>
               <a:t>Fourth level</a:t>
             </a:r>
           </a:p>
           <a:p>
             <a:pPr lvl="4"/>
             <a:r>
-              <a:rPr lang="en-US" smtClean="0"/>
+              <a:rPr lang="en-US"/>
               <a:t>Fifth level</a:t>
             </a:r>
-            <a:endParaRPr lang="en-US"/>
           </a:p>
         </p:txBody>
       </p:sp>
@@ -1766,7 +1767,7 @@
           <a:p>
             <a:fld id="{5BCAD085-E8A6-8845-BD4E-CB4CCA059FC4}" type="datetimeFigureOut">
               <a:rPr lang="en-US" smtClean="0"/>
-              <a:t>1/27/13</a:t>
+              <a:t>9/29/2026</a:t>
             </a:fld>
             <a:endParaRPr lang="en-US"/>
           </a:p>
@@ -1860,10 +1861,9 @@
           <a:lstStyle/>
           <a:p>
             <a:r>
-              <a:rPr lang="en-US" smtClean="0"/>
+              <a:rPr lang="en-US"/>
               <a:t>Click to edit Master title style</a:t>
             </a:r>
-            <a:endParaRPr lang="en-US"/>
           </a:p>
         </p:txBody>
       </p:sp>
@@ -1884,7 +1884,7 @@
           <a:p>
             <a:fld id="{5BCAD085-E8A6-8845-BD4E-CB4CCA059FC4}" type="datetimeFigureOut">
               <a:rPr lang="en-US" smtClean="0"/>
-              <a:t>1/27/13</a:t>
+              <a:t>9/29/2026</a:t>
             </a:fld>
             <a:endParaRPr lang="en-US"/>
           </a:p>
@@ -1979,7 +1979,7 @@
           <a:p>
             <a:fld id="{5BCAD085-E8A6-8845-BD4E-CB4CCA059FC4}" type="datetimeFigureOut">
               <a:rPr lang="en-US" smtClean="0"/>
-              <a:t>1/27/13</a:t>
+              <a:t>9/29/2026</a:t>
             </a:fld>
             <a:endParaRPr lang="en-US"/>
           </a:p>
@@ -2082,10 +2082,9 @@
           </a:lstStyle>
           <a:p>
             <a:r>
-              <a:rPr lang="en-US" smtClean="0"/>
+              <a:rPr lang="en-US"/>
               <a:t>Click to edit Master title style</a:t>
             </a:r>
-            <a:endParaRPr lang="en-US"/>
           </a:p>
         </p:txBody>
       </p:sp>
@@ -2139,38 +2138,37 @@
           <a:p>
             <a:pPr lvl="0"/>
             <a:r>
-              <a:rPr lang="en-US" smtClean="0"/>
+              <a:rPr lang="en-US"/>
               <a:t>Click to edit Master text styles</a:t>
             </a:r>
           </a:p>
           <a:p>
             <a:pPr lvl="1"/>
             <a:r>
-              <a:rPr lang="en-US" smtClean="0"/>
+              <a:rPr lang="en-US"/>
               <a:t>Second level</a:t>
             </a:r>
           </a:p>
           <a:p>
             <a:pPr lvl="2"/>
             <a:r>
-              <a:rPr lang="en-US" smtClean="0"/>
+              <a:rPr lang="en-US"/>
               <a:t>Third level</a:t>
             </a:r>
           </a:p>
           <a:p>
             <a:pPr lvl="3"/>
             <a:r>
-              <a:rPr lang="en-US" smtClean="0"/>
+              <a:rPr lang="en-US"/>
               <a:t>Fourth level</a:t>
             </a:r>
           </a:p>
           <a:p>
             <a:pPr lvl="4"/>
             <a:r>
-              <a:rPr lang="en-US" smtClean="0"/>
+              <a:rPr lang="en-US"/>
               <a:t>Fifth level</a:t>
             </a:r>
-            <a:endParaRPr lang="en-US"/>
           </a:p>
         </p:txBody>
       </p:sp>
@@ -2233,7 +2231,7 @@
           <a:p>
             <a:pPr lvl="0"/>
             <a:r>
-              <a:rPr lang="en-US" smtClean="0"/>
+              <a:rPr lang="en-US"/>
               <a:t>Click to edit Master text styles</a:t>
             </a:r>
           </a:p>
@@ -2256,7 +2254,7 @@
           <a:p>
             <a:fld id="{5BCAD085-E8A6-8845-BD4E-CB4CCA059FC4}" type="datetimeFigureOut">
               <a:rPr lang="en-US" smtClean="0"/>
-              <a:t>1/27/13</a:t>
+              <a:t>9/29/2026</a:t>
             </a:fld>
             <a:endParaRPr lang="en-US"/>
           </a:p>
@@ -2359,10 +2357,9 @@
           </a:lstStyle>
           <a:p>
             <a:r>
-              <a:rPr lang="en-US" smtClean="0"/>
+              <a:rPr lang="en-US"/>
               <a:t>Click to edit Master title style</a:t>
             </a:r>
-            <a:endParaRPr lang="en-US"/>
           </a:p>
         </p:txBody>
       </p:sp>
@@ -2486,7 +2483,7 @@
           <a:p>
             <a:pPr lvl="0"/>
             <a:r>
-              <a:rPr lang="en-US" smtClean="0"/>
+              <a:rPr lang="en-US"/>
               <a:t>Click to edit Master text styles</a:t>
             </a:r>
           </a:p>
@@ -2509,7 +2506,7 @@
           <a:p>
             <a:fld id="{5BCAD085-E8A6-8845-BD4E-CB4CCA059FC4}" type="datetimeFigureOut">
               <a:rPr lang="en-US" smtClean="0"/>
-              <a:t>1/27/13</a:t>
+              <a:t>9/29/2026</a:t>
             </a:fld>
             <a:endParaRPr lang="en-US"/>
           </a:p>
@@ -2618,10 +2615,9 @@
           <a:lstStyle/>
           <a:p>
             <a:r>
-              <a:rPr lang="en-US" smtClean="0"/>
+              <a:rPr lang="en-US"/>
               <a:t>Click to edit Master title style</a:t>
             </a:r>
-            <a:endParaRPr lang="en-US"/>
           </a:p>
         </p:txBody>
       </p:sp>
@@ -2652,38 +2648,37 @@
           <a:p>
             <a:pPr lvl="0"/>
             <a:r>
-              <a:rPr lang="en-US" smtClean="0"/>
+              <a:rPr lang="en-US"/>
               <a:t>Click to edit Master text styles</a:t>
             </a:r>
           </a:p>
           <a:p>
             <a:pPr lvl="1"/>
             <a:r>
-              <a:rPr lang="en-US" smtClean="0"/>
+              <a:rPr lang="en-US"/>
               <a:t>Second level</a:t>
             </a:r>
           </a:p>
           <a:p>
             <a:pPr lvl="2"/>
             <a:r>
-              <a:rPr lang="en-US" smtClean="0"/>
+              <a:rPr lang="en-US"/>
               <a:t>Third level</a:t>
             </a:r>
           </a:p>
           <a:p>
             <a:pPr lvl="3"/>
             <a:r>
-              <a:rPr lang="en-US" smtClean="0"/>
+              <a:rPr lang="en-US"/>
               <a:t>Fourth level</a:t>
             </a:r>
           </a:p>
           <a:p>
             <a:pPr lvl="4"/>
             <a:r>
-              <a:rPr lang="en-US" smtClean="0"/>
+              <a:rPr lang="en-US"/>
               <a:t>Fifth level</a:t>
             </a:r>
-            <a:endParaRPr lang="en-US"/>
           </a:p>
         </p:txBody>
       </p:sp>
@@ -2722,7 +2717,7 @@
           <a:p>
             <a:fld id="{5BCAD085-E8A6-8845-BD4E-CB4CCA059FC4}" type="datetimeFigureOut">
               <a:rPr lang="en-US" smtClean="0"/>
-              <a:t>1/27/13</a:t>
+              <a:t>9/29/2026</a:t>
             </a:fld>
             <a:endParaRPr lang="en-US"/>
           </a:p>
@@ -3081,7 +3076,7 @@
 </file>
 
 <file path=ppt/slides/slide1.xml><?xml version="1.0" encoding="utf-8"?>
-<p:sld xmlns:a="http://schemas.openxmlformats.org/drawingml/2006/main" xmlns:p="http://schemas.openxmlformats.org/presentationml/2006/main" xmlns:r="http://schemas.openxmlformats.org/officeDocument/2006/relationships">
+<p:sld xmlns:a="http://schemas.openxmlformats.org/drawingml/2006/main" xmlns:r="http://schemas.openxmlformats.org/officeDocument/2006/relationships" xmlns:p="http://schemas.openxmlformats.org/presentationml/2006/main">
   <p:cSld>
     <p:spTree>
       <p:nvGrpSpPr>
@@ -3089,7 +3084,14 @@
         <p:cNvGrpSpPr/>
         <p:nvPr/>
       </p:nvGrpSpPr>
-      <p:grpSpPr/>
+      <p:grpSpPr>
+        <a:xfrm>
+          <a:off x="0" y="0"/>
+          <a:ext cx="0" cy="0"/>
+          <a:chOff x="0" y="0"/>
+          <a:chExt cx="0" cy="0"/>
+        </a:xfrm>
+      </p:grpSpPr>
       <p:sp>
         <p:nvSpPr>
           <p:cNvPr id="2" name="Rectangle 1"/>
@@ -3132,6 +3134,7 @@
           <a:lstStyle/>
           <a:p>
             <a:pPr algn="ctr"/>
+            <a:endParaRPr/>
           </a:p>
         </p:txBody>
       </p:sp>
@@ -3177,6 +3180,7 @@
           <a:lstStyle/>
           <a:p>
             <a:pPr algn="ctr"/>
+            <a:endParaRPr/>
           </a:p>
         </p:txBody>
       </p:sp>
@@ -3269,7 +3273,7 @@
           <a:noFill/>
         </p:spPr>
         <p:txBody>
-          <a:bodyPr wrap="square" tIns="0" lIns="0">
+          <a:bodyPr wrap="square" lIns="0" tIns="0">
             <a:spAutoFit/>
           </a:bodyPr>
           <a:lstStyle/>
@@ -3346,6 +3350,7 @@
           <a:lstStyle/>
           <a:p>
             <a:pPr algn="ctr"/>
+            <a:endParaRPr/>
           </a:p>
         </p:txBody>
       </p:sp>
@@ -3526,6 +3531,7 @@
           <a:lstStyle/>
           <a:p>
             <a:pPr algn="ctr"/>
+            <a:endParaRPr/>
           </a:p>
         </p:txBody>
       </p:sp>
@@ -3728,7 +3734,7 @@
 </file>
 
 <file path=ppt/slides/slide2.xml><?xml version="1.0" encoding="utf-8"?>
-<p:sld xmlns:a="http://schemas.openxmlformats.org/drawingml/2006/main" xmlns:p="http://schemas.openxmlformats.org/presentationml/2006/main" xmlns:r="http://schemas.openxmlformats.org/officeDocument/2006/relationships">
+<p:sld xmlns:a="http://schemas.openxmlformats.org/drawingml/2006/main" xmlns:r="http://schemas.openxmlformats.org/officeDocument/2006/relationships" xmlns:p="http://schemas.openxmlformats.org/presentationml/2006/main">
   <p:cSld>
     <p:spTree>
       <p:nvGrpSpPr>
@@ -3736,7 +3742,14 @@
         <p:cNvGrpSpPr/>
         <p:nvPr/>
       </p:nvGrpSpPr>
-      <p:grpSpPr/>
+      <p:grpSpPr>
+        <a:xfrm>
+          <a:off x="0" y="0"/>
+          <a:ext cx="0" cy="0"/>
+          <a:chOff x="0" y="0"/>
+          <a:chExt cx="0" cy="0"/>
+        </a:xfrm>
+      </p:grpSpPr>
       <p:sp>
         <p:nvSpPr>
           <p:cNvPr id="2" name="Rectangle 1"/>
@@ -3779,6 +3792,7 @@
           <a:lstStyle/>
           <a:p>
             <a:pPr algn="ctr"/>
+            <a:endParaRPr/>
           </a:p>
         </p:txBody>
       </p:sp>
@@ -3824,6 +3838,7 @@
           <a:lstStyle/>
           <a:p>
             <a:pPr algn="ctr"/>
+            <a:endParaRPr/>
           </a:p>
         </p:txBody>
       </p:sp>
@@ -3916,7 +3931,7 @@
           <a:noFill/>
         </p:spPr>
         <p:txBody>
-          <a:bodyPr wrap="square" tIns="0" lIns="0">
+          <a:bodyPr wrap="square" lIns="0" tIns="0">
             <a:spAutoFit/>
           </a:bodyPr>
           <a:lstStyle/>
@@ -4017,6 +4032,7 @@
           <a:lstStyle/>
           <a:p>
             <a:pPr algn="ctr"/>
+            <a:endParaRPr/>
           </a:p>
         </p:txBody>
       </p:sp>
@@ -4283,7 +4299,7 @@
 </file>
 
 <file path=ppt/slides/slide3.xml><?xml version="1.0" encoding="utf-8"?>
-<p:sld xmlns:a="http://schemas.openxmlformats.org/drawingml/2006/main" xmlns:p="http://schemas.openxmlformats.org/presentationml/2006/main" xmlns:r="http://schemas.openxmlformats.org/officeDocument/2006/relationships">
+<p:sld xmlns:a="http://schemas.openxmlformats.org/drawingml/2006/main" xmlns:r="http://schemas.openxmlformats.org/officeDocument/2006/relationships" xmlns:p="http://schemas.openxmlformats.org/presentationml/2006/main">
   <p:cSld>
     <p:spTree>
       <p:nvGrpSpPr>
@@ -4291,7 +4307,14 @@
         <p:cNvGrpSpPr/>
         <p:nvPr/>
       </p:nvGrpSpPr>
-      <p:grpSpPr/>
+      <p:grpSpPr>
+        <a:xfrm>
+          <a:off x="0" y="0"/>
+          <a:ext cx="0" cy="0"/>
+          <a:chOff x="0" y="0"/>
+          <a:chExt cx="0" cy="0"/>
+        </a:xfrm>
+      </p:grpSpPr>
       <p:sp>
         <p:nvSpPr>
           <p:cNvPr id="2" name="Rectangle 1"/>
@@ -4334,6 +4357,7 @@
           <a:lstStyle/>
           <a:p>
             <a:pPr algn="ctr"/>
+            <a:endParaRPr/>
           </a:p>
         </p:txBody>
       </p:sp>
@@ -4379,6 +4403,7 @@
           <a:lstStyle/>
           <a:p>
             <a:pPr algn="ctr"/>
+            <a:endParaRPr/>
           </a:p>
         </p:txBody>
       </p:sp>
@@ -4471,7 +4496,7 @@
           <a:noFill/>
         </p:spPr>
         <p:txBody>
-          <a:bodyPr wrap="square" tIns="0" lIns="0">
+          <a:bodyPr wrap="square" lIns="0" tIns="0">
             <a:spAutoFit/>
           </a:bodyPr>
           <a:lstStyle/>
@@ -4548,6 +4573,7 @@
           <a:lstStyle/>
           <a:p>
             <a:pPr algn="ctr"/>
+            <a:endParaRPr/>
           </a:p>
         </p:txBody>
       </p:sp>
@@ -4760,6 +4786,7 @@
           <a:lstStyle/>
           <a:p>
             <a:pPr algn="ctr"/>
+            <a:endParaRPr/>
           </a:p>
         </p:txBody>
       </p:sp>
@@ -4948,8 +4975,18 @@
               </a:defRPr>
             </a:pPr>
             <a:r>
-              <a:t>🎯 MEMORIX  •  Proyecto Intermodular 2º DAM  •  Kevin Muñoz Córcoles</a:t>
-            </a:r>
+              <a:rPr dirty="0"/>
+              <a:t>🎯 MEMORIX  •  Proyecto Intermodular 2º DAM  •  Kevin Muñoz C</a:t>
+            </a:r>
+            <a:r>
+              <a:rPr lang="ca-ES-valencia" dirty="0"/>
+              <a:t>o</a:t>
+            </a:r>
+            <a:r>
+              <a:rPr dirty="0" err="1"/>
+              <a:t>rcoles</a:t>
+            </a:r>
+            <a:endParaRPr dirty="0"/>
           </a:p>
         </p:txBody>
       </p:sp>

</xml_diff>